<commit_message>
EDFS-10: streamline pre-defense package (assistant-prepared, student review required)
</commit_message>
<xml_diff>
--- a/docs/EDFS_Predefense_1_2026-10-24.pptx
+++ b/docs/EDFS_Predefense_1_2026-10-24.pptx
@@ -2,24 +2,24 @@
 <file path=ppt/presentation.xml><?xml version="1.0" encoding="utf-8"?>
 <p:presentation xmlns:p="http://schemas.openxmlformats.org/presentationml/2006/main">
   <p:sldMasterIdLst>
-    <p:sldMasterId xmlns:r="http://schemas.openxmlformats.org/officeDocument/2006/relationships" id="2147483648" r:id="R57e1653e61df4b69"/>
+    <p:sldMasterId xmlns:r="http://schemas.openxmlformats.org/officeDocument/2006/relationships" id="2147483648" r:id="R9ec7ab8ca32c453e"/>
   </p:sldMasterIdLst>
   <p:notesMasterIdLst>
-    <p:notesMasterId xmlns:r="http://schemas.openxmlformats.org/officeDocument/2006/relationships" r:id="R3407d4bf3b9d4bbe"/>
+    <p:notesMasterId xmlns:r="http://schemas.openxmlformats.org/officeDocument/2006/relationships" r:id="R92696ae8a2db4dfe"/>
   </p:notesMasterIdLst>
   <p:sldIdLst>
-    <p:sldId xmlns:r="http://schemas.openxmlformats.org/officeDocument/2006/relationships" id="256" r:id="R95f798e69b04462d"/>
-    <p:sldId xmlns:r="http://schemas.openxmlformats.org/officeDocument/2006/relationships" id="257" r:id="R7ac32074d62148d1"/>
-    <p:sldId xmlns:r="http://schemas.openxmlformats.org/officeDocument/2006/relationships" id="258" r:id="R7d959b2b2e6c4d9e"/>
-    <p:sldId xmlns:r="http://schemas.openxmlformats.org/officeDocument/2006/relationships" id="259" r:id="R2ca988daacaa46e8"/>
-    <p:sldId xmlns:r="http://schemas.openxmlformats.org/officeDocument/2006/relationships" id="260" r:id="Rbde8e74020474440"/>
-    <p:sldId xmlns:r="http://schemas.openxmlformats.org/officeDocument/2006/relationships" id="261" r:id="R8b07279c46e54fdb"/>
-    <p:sldId xmlns:r="http://schemas.openxmlformats.org/officeDocument/2006/relationships" id="262" r:id="R24f293c5562b4a27"/>
-    <p:sldId xmlns:r="http://schemas.openxmlformats.org/officeDocument/2006/relationships" id="263" r:id="R32289428f6a2428c"/>
-    <p:sldId xmlns:r="http://schemas.openxmlformats.org/officeDocument/2006/relationships" id="264" r:id="R01babd71fa2948b8"/>
-    <p:sldId xmlns:r="http://schemas.openxmlformats.org/officeDocument/2006/relationships" id="265" r:id="Rb829304936ae4fb5"/>
-    <p:sldId xmlns:r="http://schemas.openxmlformats.org/officeDocument/2006/relationships" id="266" r:id="R09adec2b31834c60"/>
-    <p:sldId xmlns:r="http://schemas.openxmlformats.org/officeDocument/2006/relationships" id="267" r:id="R9e17dbf166e24a9e"/>
+    <p:sldId xmlns:r="http://schemas.openxmlformats.org/officeDocument/2006/relationships" id="256" r:id="R9b6b2559330f4f06"/>
+    <p:sldId xmlns:r="http://schemas.openxmlformats.org/officeDocument/2006/relationships" id="257" r:id="R62205ab9916e45bc"/>
+    <p:sldId xmlns:r="http://schemas.openxmlformats.org/officeDocument/2006/relationships" id="258" r:id="Re204b6d7c522409d"/>
+    <p:sldId xmlns:r="http://schemas.openxmlformats.org/officeDocument/2006/relationships" id="259" r:id="Rbee68d6d099a4673"/>
+    <p:sldId xmlns:r="http://schemas.openxmlformats.org/officeDocument/2006/relationships" id="260" r:id="R8d69e1bed0b54097"/>
+    <p:sldId xmlns:r="http://schemas.openxmlformats.org/officeDocument/2006/relationships" id="261" r:id="R68978064eaec4128"/>
+    <p:sldId xmlns:r="http://schemas.openxmlformats.org/officeDocument/2006/relationships" id="262" r:id="R5c63190f276f4fac"/>
+    <p:sldId xmlns:r="http://schemas.openxmlformats.org/officeDocument/2006/relationships" id="263" r:id="R0994da47e49c43f2"/>
+    <p:sldId xmlns:r="http://schemas.openxmlformats.org/officeDocument/2006/relationships" id="264" r:id="R654c09b697f245a8"/>
+    <p:sldId xmlns:r="http://schemas.openxmlformats.org/officeDocument/2006/relationships" id="265" r:id="Re7910ac98ab54321"/>
+    <p:sldId xmlns:r="http://schemas.openxmlformats.org/officeDocument/2006/relationships" id="266" r:id="Rea452c41e8894b24"/>
+    <p:sldId xmlns:r="http://schemas.openxmlformats.org/officeDocument/2006/relationships" id="267" r:id="R1747015f92f143c8"/>
   </p:sldIdLst>
   <p:sldSz cx="12192000" cy="6858000"/>
   <p:notesSz cx="6858000" cy="9144000"/>
@@ -593,7 +593,7 @@
           <a:lstStyle xmlns:a="http://schemas.openxmlformats.org/drawingml/2006/main"/>
           <a:p xmlns:a="http://schemas.openxmlformats.org/drawingml/2006/main">
             <a:r>
-              <a:t>Источники: docs/09_verification.md, evidence/verification.md, tests/. Прохождение 15 тестов относится только к модели браузерного прототипа, не доказывает серверную безопасность или улучшение процесса у пользователей.</a:t>
+              <a:t>Источники: docs/09_verification.md, docs/evaluation/, evidence/verification.md, tests/. Существующие 15 модельных проверок прошли, но новые тесты для этой аналитической сдачи не добавлялись. Они не доказывают серверную безопасность или улучшение процесса у пользователей.</a:t>
             </a:r>
           </a:p>
         </p:txBody>
@@ -663,7 +663,7 @@
           <a:lstStyle xmlns:a="http://schemas.openxmlformats.org/drawingml/2006/main"/>
           <a:p xmlns:a="http://schemas.openxmlformats.org/drawingml/2006/main">
             <a:r>
-              <a:t>Источники: README.md, docs/11_supervision_readiness.md, management/online_status.md. PR #1 и #2 слиты без отправленного peer review; нельзя считать это условие закрытым задним числом. Отзыв руководителя и tag pre-defense-1 не подтверждены. После подготовки этого переносимого PPTX проверьте доступ членов комиссии к самому файлу.</a:t>
+              <a:t>Источники: README.md, docs/11_supervision_readiness.md, management/online_status.md. PR #1, #2 и #3 слиты без отправленного peer review; нельзя считать это условие закрытым задним числом. Отзыв руководителя и tag pre-defense-1 не подтверждены. Проверьте доступ членов комиссии к этому переносимому PPTX.</a:t>
             </a:r>
           </a:p>
         </p:txBody>
@@ -1153,7 +1153,7 @@
           <a:lstStyle xmlns:a="http://schemas.openxmlformats.org/drawingml/2006/main"/>
           <a:p xmlns:a="http://schemas.openxmlformats.org/drawingml/2006/main">
             <a:r>
-              <a:t>Источники: docs/07_architecture.md, diagrams/context.drawio. В репозитории есть шесть редактируемых исходников draw.io с SVG/PNG экспортами. Изображённая серверная система пока проектируется.</a:t>
+              <a:t>Источники: docs/07_architecture.md, diagrams/context.drawio. В репозитории есть три обязательные редактируемые схемы draw.io: контекст, UML-варианты использования и черновые UML-компоненты. У каждой есть SVG/PNG экспорт. Изображённая серверная система пока проектируется.</a:t>
             </a:r>
           </a:p>
         </p:txBody>
@@ -1223,7 +1223,7 @@
           <a:lstStyle xmlns:a="http://schemas.openxmlformats.org/drawingml/2006/main"/>
           <a:p xmlns:a="http://schemas.openxmlformats.org/drawingml/2006/main">
             <a:r>
-              <a:t>Источники: docs/06_requirements.md, docs/07_architecture.md, diagrams/state.drawio. Схема ограниченного процесса: черновик, на согласовании, правки, согласовано, архив. CR01 многоэтапного маршрута не реализован.</a:t>
+              <a:t>Источники: docs/06_requirements.md, docs/07_architecture.md, diagrams/use_cases.drawio. Диаграмма показывает авторские, рецензентские и административные сценарии. CR01 многоэтапного маршрута пока не реализован.</a:t>
             </a:r>
           </a:p>
         </p:txBody>
@@ -1270,7 +1270,7 @@
           <p:cNvPr id="3" name="Title">
             <a:extLst xmlns:a="http://schemas.openxmlformats.org/drawingml/2006/main">
               <a:ext uri="{FF2B5EF4-FFF2-40B4-BE49-F238E27FC236}">
-                <a16:creationId xmlns:a16="http://schemas.microsoft.com/office/drawing/2014/main" id="{0AD6A2C1-57B0-4ADE-8D2F-453B4A58EF86}"/>
+                <a16:creationId xmlns:a16="http://schemas.microsoft.com/office/drawing/2014/main" id="{E6922A50-C633-4A9B-99FC-7E8D3117800B}"/>
               </a:ext>
             </a:extLst>
           </p:cNvPr>
@@ -1499,7 +1499,7 @@
           <p:cNvPr id="2" name="Subtitle">
             <a:extLst xmlns:a="http://schemas.openxmlformats.org/drawingml/2006/main">
               <a:ext uri="{FF2B5EF4-FFF2-40B4-BE49-F238E27FC236}">
-                <a16:creationId xmlns:a16="http://schemas.microsoft.com/office/drawing/2014/main" id="{2CD3C122-1EB4-4FF9-95D7-016FD0C38DBA}"/>
+                <a16:creationId xmlns:a16="http://schemas.microsoft.com/office/drawing/2014/main" id="{8969539D-EA8F-450F-97C1-C2D88E5B301A}"/>
               </a:ext>
             </a:extLst>
           </p:cNvPr>
@@ -1745,7 +1745,7 @@
           <p:cNvPr id="2" name="Section title">
             <a:extLst xmlns:a="http://schemas.openxmlformats.org/drawingml/2006/main">
               <a:ext uri="{FF2B5EF4-FFF2-40B4-BE49-F238E27FC236}">
-                <a16:creationId xmlns:a16="http://schemas.microsoft.com/office/drawing/2014/main" id="{3EECF6F8-D7C7-483A-B2EF-B95E7E857270}"/>
+                <a16:creationId xmlns:a16="http://schemas.microsoft.com/office/drawing/2014/main" id="{9C35EEE0-0C33-4574-AB6E-5C0A3C203B7B}"/>
               </a:ext>
             </a:extLst>
           </p:cNvPr>
@@ -1991,7 +1991,7 @@
           <p:cNvPr id="3" name="Title">
             <a:extLst xmlns:a="http://schemas.openxmlformats.org/drawingml/2006/main">
               <a:ext uri="{FF2B5EF4-FFF2-40B4-BE49-F238E27FC236}">
-                <a16:creationId xmlns:a16="http://schemas.microsoft.com/office/drawing/2014/main" id="{234957A9-9331-4199-B647-016D591CA378}"/>
+                <a16:creationId xmlns:a16="http://schemas.microsoft.com/office/drawing/2014/main" id="{DCF1A736-2D3B-4006-A82D-65986F987A83}"/>
               </a:ext>
             </a:extLst>
           </p:cNvPr>
@@ -2220,7 +2220,7 @@
           <p:cNvPr id="2" name="Body">
             <a:extLst xmlns:a="http://schemas.openxmlformats.org/drawingml/2006/main">
               <a:ext uri="{FF2B5EF4-FFF2-40B4-BE49-F238E27FC236}">
-                <a16:creationId xmlns:a16="http://schemas.microsoft.com/office/drawing/2014/main" id="{9640F9A7-B0E2-4A3A-A87C-B3E9ECFB82AD}"/>
+                <a16:creationId xmlns:a16="http://schemas.microsoft.com/office/drawing/2014/main" id="{8F375A98-AAE2-4B30-BBB6-8BB33782A5DB}"/>
               </a:ext>
             </a:extLst>
           </p:cNvPr>
@@ -2466,7 +2466,7 @@
           <p:cNvPr id="4" name="Title">
             <a:extLst xmlns:a="http://schemas.openxmlformats.org/drawingml/2006/main">
               <a:ext uri="{FF2B5EF4-FFF2-40B4-BE49-F238E27FC236}">
-                <a16:creationId xmlns:a16="http://schemas.microsoft.com/office/drawing/2014/main" id="{F47748FD-973A-4928-A970-9B09C43ACE13}"/>
+                <a16:creationId xmlns:a16="http://schemas.microsoft.com/office/drawing/2014/main" id="{0B053F9C-49A6-41DC-A6B1-298ECDC9AB48}"/>
               </a:ext>
             </a:extLst>
           </p:cNvPr>
@@ -2695,7 +2695,7 @@
           <p:cNvPr id="2" name="Left column">
             <a:extLst xmlns:a="http://schemas.openxmlformats.org/drawingml/2006/main">
               <a:ext uri="{FF2B5EF4-FFF2-40B4-BE49-F238E27FC236}">
-                <a16:creationId xmlns:a16="http://schemas.microsoft.com/office/drawing/2014/main" id="{25F75321-6454-457D-8595-EC81838D4E2A}"/>
+                <a16:creationId xmlns:a16="http://schemas.microsoft.com/office/drawing/2014/main" id="{D2336FD5-3207-43CC-90DD-1168F17537B5}"/>
               </a:ext>
             </a:extLst>
           </p:cNvPr>
@@ -2924,7 +2924,7 @@
           <p:cNvPr id="3" name="Right column">
             <a:extLst xmlns:a="http://schemas.openxmlformats.org/drawingml/2006/main">
               <a:ext uri="{FF2B5EF4-FFF2-40B4-BE49-F238E27FC236}">
-                <a16:creationId xmlns:a16="http://schemas.microsoft.com/office/drawing/2014/main" id="{0E229124-83A7-4DC0-9E89-03F9E82A6571}"/>
+                <a16:creationId xmlns:a16="http://schemas.microsoft.com/office/drawing/2014/main" id="{EE632194-6F16-43FA-B9FE-A2B0B7442DBD}"/>
               </a:ext>
             </a:extLst>
           </p:cNvPr>
@@ -3170,7 +3170,7 @@
           <p:cNvPr id="3" name="Title">
             <a:extLst xmlns:a="http://schemas.openxmlformats.org/drawingml/2006/main">
               <a:ext uri="{FF2B5EF4-FFF2-40B4-BE49-F238E27FC236}">
-                <a16:creationId xmlns:a16="http://schemas.microsoft.com/office/drawing/2014/main" id="{983B8522-ACB1-40D1-BBB0-51A9AD1B701B}"/>
+                <a16:creationId xmlns:a16="http://schemas.microsoft.com/office/drawing/2014/main" id="{898542B2-AC0F-4EBB-B920-1B9B1E027E5E}"/>
               </a:ext>
             </a:extLst>
           </p:cNvPr>
@@ -3399,7 +3399,7 @@
           <p:cNvPr id="2" name="Left column">
             <a:extLst xmlns:a="http://schemas.openxmlformats.org/drawingml/2006/main">
               <a:ext uri="{FF2B5EF4-FFF2-40B4-BE49-F238E27FC236}">
-                <a16:creationId xmlns:a16="http://schemas.microsoft.com/office/drawing/2014/main" id="{B335AAA6-8318-4B2B-AC8F-9A49D88E3B93}"/>
+                <a16:creationId xmlns:a16="http://schemas.microsoft.com/office/drawing/2014/main" id="{55723817-CA1C-4F94-8619-85E0825B785A}"/>
               </a:ext>
             </a:extLst>
           </p:cNvPr>
@@ -3666,12 +3666,12 @@
   </p:cSld>
   <p:clrMap bg1="lt1" tx1="dk1" bg2="lt2" tx2="dk2" accent1="accent1" accent2="accent2" accent3="accent3" accent4="accent4" accent5="accent5" accent6="accent6" hlink="hlink" folHlink="folHlink"/>
   <p:sldLayoutIdLst>
-    <p:sldLayoutId xmlns:r="http://schemas.openxmlformats.org/officeDocument/2006/relationships" id="2147483649" r:id="R260a8edd758e4eb0"/>
-    <p:sldLayoutId xmlns:r="http://schemas.openxmlformats.org/officeDocument/2006/relationships" id="2147483650" r:id="R6d5caa010780499f"/>
-    <p:sldLayoutId xmlns:r="http://schemas.openxmlformats.org/officeDocument/2006/relationships" id="2147483651" r:id="R9d315bab05704e17"/>
-    <p:sldLayoutId xmlns:r="http://schemas.openxmlformats.org/officeDocument/2006/relationships" id="2147483652" r:id="R074b9b467e8f4087"/>
-    <p:sldLayoutId xmlns:r="http://schemas.openxmlformats.org/officeDocument/2006/relationships" id="2147483653" r:id="R0e0a9966362a4e1a"/>
-    <p:sldLayoutId xmlns:r="http://schemas.openxmlformats.org/officeDocument/2006/relationships" id="2147483654" r:id="Ra1cc0c4ad0ba4637"/>
+    <p:sldLayoutId xmlns:r="http://schemas.openxmlformats.org/officeDocument/2006/relationships" id="2147483649" r:id="Rb7cd7c8f37474edc"/>
+    <p:sldLayoutId xmlns:r="http://schemas.openxmlformats.org/officeDocument/2006/relationships" id="2147483650" r:id="Raf12563ffce24501"/>
+    <p:sldLayoutId xmlns:r="http://schemas.openxmlformats.org/officeDocument/2006/relationships" id="2147483651" r:id="R03c7448859314b04"/>
+    <p:sldLayoutId xmlns:r="http://schemas.openxmlformats.org/officeDocument/2006/relationships" id="2147483652" r:id="R298f567ff0c84315"/>
+    <p:sldLayoutId xmlns:r="http://schemas.openxmlformats.org/officeDocument/2006/relationships" id="2147483653" r:id="Rfe4fb177573a40f8"/>
+    <p:sldLayoutId xmlns:r="http://schemas.openxmlformats.org/officeDocument/2006/relationships" id="2147483654" r:id="R66577653f5944f6f"/>
   </p:sldLayoutIdLst>
   <p:txStyles>
     <p:titleStyle>
@@ -4222,7 +4222,7 @@
           <p:cNvPr id="5" name="">
             <a:extLst xmlns:a="http://schemas.openxmlformats.org/drawingml/2006/main">
               <a:ext uri="{FF2B5EF4-FFF2-40B4-BE49-F238E27FC236}">
-                <a16:creationId xmlns:a16="http://schemas.microsoft.com/office/drawing/2014/main" id="{69BE9CF4-585E-49C8-AEC2-154A61E02E00}"/>
+                <a16:creationId xmlns:a16="http://schemas.microsoft.com/office/drawing/2014/main" id="{20606CB4-2CE0-4B35-BC92-30702A12B4F6}"/>
               </a:ext>
             </a:extLst>
           </p:cNvPr>
@@ -4360,7 +4360,7 @@
           <p:cNvPr id="2" name="">
             <a:extLst xmlns:a="http://schemas.openxmlformats.org/drawingml/2006/main">
               <a:ext uri="{FF2B5EF4-FFF2-40B4-BE49-F238E27FC236}">
-                <a16:creationId xmlns:a16="http://schemas.microsoft.com/office/drawing/2014/main" id="{95F54BC9-7E09-4EC3-9BC4-9E00597D8D30}"/>
+                <a16:creationId xmlns:a16="http://schemas.microsoft.com/office/drawing/2014/main" id="{B32BA6C5-B28B-4314-8080-958962274489}"/>
               </a:ext>
             </a:extLst>
           </p:cNvPr>
@@ -4481,7 +4481,7 @@
           <p:cNvPr id="3" name="">
             <a:extLst xmlns:a="http://schemas.openxmlformats.org/drawingml/2006/main">
               <a:ext uri="{FF2B5EF4-FFF2-40B4-BE49-F238E27FC236}">
-                <a16:creationId xmlns:a16="http://schemas.microsoft.com/office/drawing/2014/main" id="{C20899F3-705D-45A7-B2EB-6C4991E5D1A1}"/>
+                <a16:creationId xmlns:a16="http://schemas.microsoft.com/office/drawing/2014/main" id="{4EC46CB9-963F-4730-B673-6EEE613348AD}"/>
               </a:ext>
             </a:extLst>
           </p:cNvPr>
@@ -4602,7 +4602,7 @@
           <p:cNvPr id="4" name="">
             <a:extLst xmlns:a="http://schemas.openxmlformats.org/drawingml/2006/main">
               <a:ext uri="{FF2B5EF4-FFF2-40B4-BE49-F238E27FC236}">
-                <a16:creationId xmlns:a16="http://schemas.microsoft.com/office/drawing/2014/main" id="{BC6DDA48-67F5-4476-A9F2-BBFC65EAD665}"/>
+                <a16:creationId xmlns:a16="http://schemas.microsoft.com/office/drawing/2014/main" id="{396C06B8-5390-47EA-B85F-FD5962DB4A43}"/>
               </a:ext>
             </a:extLst>
           </p:cNvPr>
@@ -4721,7 +4721,7 @@
     </p:spTree>
     <p:extLst>
       <p:ext uri="{BB962C8B-B14F-4D97-AF65-F5344CB8AC3E}">
-        <p14:creationId xmlns:p14="http://schemas.microsoft.com/office/powerpoint/2010/main" val="1253152751"/>
+        <p14:creationId xmlns:p14="http://schemas.microsoft.com/office/powerpoint/2010/main" val="600572854"/>
       </p:ext>
     </p:extLst>
   </p:cSld>
@@ -4752,7 +4752,7 @@
           <p:cNvPr id="7" name="">
             <a:extLst xmlns:a="http://schemas.openxmlformats.org/drawingml/2006/main">
               <a:ext uri="{FF2B5EF4-FFF2-40B4-BE49-F238E27FC236}">
-                <a16:creationId xmlns:a16="http://schemas.microsoft.com/office/drawing/2014/main" id="{112CA4C9-2C1A-4588-9C3C-6E9501C7EAFF}"/>
+                <a16:creationId xmlns:a16="http://schemas.microsoft.com/office/drawing/2014/main" id="{F905F02C-9226-48B9-ABFA-03A3AEF20F0F}"/>
               </a:ext>
             </a:extLst>
           </p:cNvPr>
@@ -4873,7 +4873,7 @@
           <p:cNvPr id="2" name="">
             <a:extLst xmlns:a="http://schemas.openxmlformats.org/drawingml/2006/main">
               <a:ext uri="{FF2B5EF4-FFF2-40B4-BE49-F238E27FC236}">
-                <a16:creationId xmlns:a16="http://schemas.microsoft.com/office/drawing/2014/main" id="{4896AE3F-1AFB-47F6-9F56-8114077885D2}"/>
+                <a16:creationId xmlns:a16="http://schemas.microsoft.com/office/drawing/2014/main" id="{252CC3C7-83E0-4586-8951-E0C9F230598F}"/>
               </a:ext>
             </a:extLst>
           </p:cNvPr>
@@ -4994,7 +4994,7 @@
           <p:cNvPr id="3" name="">
             <a:extLst xmlns:a="http://schemas.openxmlformats.org/drawingml/2006/main">
               <a:ext uri="{FF2B5EF4-FFF2-40B4-BE49-F238E27FC236}">
-                <a16:creationId xmlns:a16="http://schemas.microsoft.com/office/drawing/2014/main" id="{B0DF2517-DC8C-4BE4-BA78-EFD27A96C15B}"/>
+                <a16:creationId xmlns:a16="http://schemas.microsoft.com/office/drawing/2014/main" id="{30D96295-D21E-4449-B07A-D7F4F2AF7EFB}"/>
               </a:ext>
             </a:extLst>
           </p:cNvPr>
@@ -5004,7 +5004,7 @@
           <p:nvPr/>
         </p:nvPicPr>
         <p:blipFill>
-          <a:blip xmlns:r="http://schemas.openxmlformats.org/officeDocument/2006/relationships" xmlns:a="http://schemas.openxmlformats.org/drawingml/2006/main" r:embed="R8ef2c478fc194c43"/>
+          <a:blip xmlns:r="http://schemas.openxmlformats.org/officeDocument/2006/relationships" xmlns:a="http://schemas.openxmlformats.org/drawingml/2006/main" r:embed="Rea2c2b6b8f154fe1"/>
           <a:stretch xmlns:a="http://schemas.openxmlformats.org/drawingml/2006/main"/>
         </p:blipFill>
         <p:spPr>
@@ -5022,7 +5022,7 @@
           <p:cNvPr id="4" name="">
             <a:extLst xmlns:a="http://schemas.openxmlformats.org/drawingml/2006/main">
               <a:ext uri="{FF2B5EF4-FFF2-40B4-BE49-F238E27FC236}">
-                <a16:creationId xmlns:a16="http://schemas.microsoft.com/office/drawing/2014/main" id="{B63072FC-23C2-471C-BCEE-E6529C14C0E4}"/>
+                <a16:creationId xmlns:a16="http://schemas.microsoft.com/office/drawing/2014/main" id="{15134632-2ECC-4F00-93AF-B29CC09B17FF}"/>
               </a:ext>
             </a:extLst>
           </p:cNvPr>
@@ -5143,7 +5143,7 @@
           <p:cNvPr id="5" name="">
             <a:extLst xmlns:a="http://schemas.openxmlformats.org/drawingml/2006/main">
               <a:ext uri="{FF2B5EF4-FFF2-40B4-BE49-F238E27FC236}">
-                <a16:creationId xmlns:a16="http://schemas.microsoft.com/office/drawing/2014/main" id="{62B9EC15-8C07-4EA6-A773-3D984731C777}"/>
+                <a16:creationId xmlns:a16="http://schemas.microsoft.com/office/drawing/2014/main" id="{64C88B6B-2D32-40A2-AFCE-937DA8FF910E}"/>
               </a:ext>
             </a:extLst>
           </p:cNvPr>
@@ -5264,7 +5264,7 @@
           <p:cNvPr id="6" name="">
             <a:extLst xmlns:a="http://schemas.openxmlformats.org/drawingml/2006/main">
               <a:ext uri="{FF2B5EF4-FFF2-40B4-BE49-F238E27FC236}">
-                <a16:creationId xmlns:a16="http://schemas.microsoft.com/office/drawing/2014/main" id="{4DD7DE31-9C68-4568-90A7-2B7F5D4ECEE8}"/>
+                <a16:creationId xmlns:a16="http://schemas.microsoft.com/office/drawing/2014/main" id="{DCBED196-C0A7-49A4-80A5-585396183A5C}"/>
               </a:ext>
             </a:extLst>
           </p:cNvPr>
@@ -5383,7 +5383,7 @@
     </p:spTree>
     <p:extLst>
       <p:ext uri="{BB962C8B-B14F-4D97-AF65-F5344CB8AC3E}">
-        <p14:creationId xmlns:p14="http://schemas.microsoft.com/office/powerpoint/2010/main" val="292908580"/>
+        <p14:creationId xmlns:p14="http://schemas.microsoft.com/office/powerpoint/2010/main" val="1179092837"/>
       </p:ext>
     </p:extLst>
   </p:cSld>
@@ -5414,7 +5414,7 @@
           <p:cNvPr id="8" name="">
             <a:extLst xmlns:a="http://schemas.openxmlformats.org/drawingml/2006/main">
               <a:ext uri="{FF2B5EF4-FFF2-40B4-BE49-F238E27FC236}">
-                <a16:creationId xmlns:a16="http://schemas.microsoft.com/office/drawing/2014/main" id="{FAE880C8-C790-4903-8D37-F31538BFD4E6}"/>
+                <a16:creationId xmlns:a16="http://schemas.microsoft.com/office/drawing/2014/main" id="{859AA3FA-4B31-4285-A81E-128E28DD541B}"/>
               </a:ext>
             </a:extLst>
           </p:cNvPr>
@@ -5525,7 +5525,7 @@
                   <a:srgbClr val="152C3D"/>
                 </a:solidFill>
               </a:rPr>
-              <a:t>Как проверяем результат</a:t>
+              <a:t>План проверки</a:t>
             </a:r>
           </a:p>
         </p:txBody>
@@ -5535,7 +5535,7 @@
           <p:cNvPr id="2" name="">
             <a:extLst xmlns:a="http://schemas.openxmlformats.org/drawingml/2006/main">
               <a:ext uri="{FF2B5EF4-FFF2-40B4-BE49-F238E27FC236}">
-                <a16:creationId xmlns:a16="http://schemas.microsoft.com/office/drawing/2014/main" id="{5F6205C7-2DCB-4136-825B-531E12232D87}"/>
+                <a16:creationId xmlns:a16="http://schemas.microsoft.com/office/drawing/2014/main" id="{76E47E32-C9B1-4A12-896F-A5EA79D85D93}"/>
               </a:ext>
             </a:extLst>
           </p:cNvPr>
@@ -5656,7 +5656,7 @@
           <p:cNvPr id="3" name="">
             <a:extLst xmlns:a="http://schemas.openxmlformats.org/drawingml/2006/main">
               <a:ext uri="{FF2B5EF4-FFF2-40B4-BE49-F238E27FC236}">
-                <a16:creationId xmlns:a16="http://schemas.microsoft.com/office/drawing/2014/main" id="{73C8AFD2-C9EE-4E69-B352-1F5D84C3BAD5}"/>
+                <a16:creationId xmlns:a16="http://schemas.microsoft.com/office/drawing/2014/main" id="{C9243685-B42A-42E8-AD7D-0B94AD24E0C5}"/>
               </a:ext>
             </a:extLst>
           </p:cNvPr>
@@ -5777,7 +5777,7 @@
           <p:cNvPr id="4" name="">
             <a:extLst xmlns:a="http://schemas.openxmlformats.org/drawingml/2006/main">
               <a:ext uri="{FF2B5EF4-FFF2-40B4-BE49-F238E27FC236}">
-                <a16:creationId xmlns:a16="http://schemas.microsoft.com/office/drawing/2014/main" id="{0963E17A-BCBD-47BE-86DD-48A7877BF32A}"/>
+                <a16:creationId xmlns:a16="http://schemas.microsoft.com/office/drawing/2014/main" id="{92F3E695-DF26-42D8-A027-7180F3316D66}"/>
               </a:ext>
             </a:extLst>
           </p:cNvPr>
@@ -5888,7 +5888,7 @@
                   <a:srgbClr val="152C3D"/>
                 </a:solidFill>
               </a:rPr>
-              <a:t>15 тестов модели прототипа прошли: переходы состояний, версия, отказ в действии, повторное решение, архив.</a:t>
+              <a:t>Описаны сценарии, критерии приёмки, метрики и условия сравнения. Папка tests сохранена для следующих этапов.</a:t>
             </a:r>
           </a:p>
         </p:txBody>
@@ -5898,7 +5898,7 @@
           <p:cNvPr id="5" name="">
             <a:extLst xmlns:a="http://schemas.openxmlformats.org/drawingml/2006/main">
               <a:ext uri="{FF2B5EF4-FFF2-40B4-BE49-F238E27FC236}">
-                <a16:creationId xmlns:a16="http://schemas.microsoft.com/office/drawing/2014/main" id="{04E7421F-A8C5-4262-8DBE-E090769FF00E}"/>
+                <a16:creationId xmlns:a16="http://schemas.microsoft.com/office/drawing/2014/main" id="{C10E9DBF-BDC4-4E99-8388-289BA917AF6B}"/>
               </a:ext>
             </a:extLst>
           </p:cNvPr>
@@ -6019,7 +6019,7 @@
           <p:cNvPr id="6" name="">
             <a:extLst xmlns:a="http://schemas.openxmlformats.org/drawingml/2006/main">
               <a:ext uri="{FF2B5EF4-FFF2-40B4-BE49-F238E27FC236}">
-                <a16:creationId xmlns:a16="http://schemas.microsoft.com/office/drawing/2014/main" id="{C6156DBC-6887-40DD-B242-C088896A72E6}"/>
+                <a16:creationId xmlns:a16="http://schemas.microsoft.com/office/drawing/2014/main" id="{E0D8F0CD-5C13-4494-9B9D-53AB133762AD}"/>
               </a:ext>
             </a:extLst>
           </p:cNvPr>
@@ -6130,7 +6130,7 @@
                   <a:srgbClr val="152C3D"/>
                 </a:solidFill>
               </a:rPr>
-              <a:t>API и права доступа на сервере, конкурентные решения, отказоустойчивость и исследование задач с пользователями.</a:t>
+              <a:t>После реализации сервера проверим права доступа, одновременные решения и восстановление. Затем проведём исследование задач с пользователями.</a:t>
             </a:r>
           </a:p>
         </p:txBody>
@@ -6140,7 +6140,7 @@
           <p:cNvPr id="7" name="">
             <a:extLst xmlns:a="http://schemas.openxmlformats.org/drawingml/2006/main">
               <a:ext uri="{FF2B5EF4-FFF2-40B4-BE49-F238E27FC236}">
-                <a16:creationId xmlns:a16="http://schemas.microsoft.com/office/drawing/2014/main" id="{ED63F6CF-7CCE-423C-ABF8-BC1072AABDCF}"/>
+                <a16:creationId xmlns:a16="http://schemas.microsoft.com/office/drawing/2014/main" id="{E0FEE8A1-E561-44C4-A9B7-C903B9BFBCF1}"/>
               </a:ext>
             </a:extLst>
           </p:cNvPr>
@@ -6259,7 +6259,7 @@
     </p:spTree>
     <p:extLst>
       <p:ext uri="{BB962C8B-B14F-4D97-AF65-F5344CB8AC3E}">
-        <p14:creationId xmlns:p14="http://schemas.microsoft.com/office/powerpoint/2010/main" val="1708360347"/>
+        <p14:creationId xmlns:p14="http://schemas.microsoft.com/office/powerpoint/2010/main" val="163793746"/>
       </p:ext>
     </p:extLst>
   </p:cSld>
@@ -6290,7 +6290,7 @@
           <p:cNvPr id="7" name="">
             <a:extLst xmlns:a="http://schemas.openxmlformats.org/drawingml/2006/main">
               <a:ext uri="{FF2B5EF4-FFF2-40B4-BE49-F238E27FC236}">
-                <a16:creationId xmlns:a16="http://schemas.microsoft.com/office/drawing/2014/main" id="{1F1FA91C-A7DD-4E8E-AC17-E654BDE3E231}"/>
+                <a16:creationId xmlns:a16="http://schemas.microsoft.com/office/drawing/2014/main" id="{EA04D243-AD6C-44B3-A7B8-1D4688EA12B6}"/>
               </a:ext>
             </a:extLst>
           </p:cNvPr>
@@ -6411,7 +6411,7 @@
           <p:cNvPr id="2" name="">
             <a:extLst xmlns:a="http://schemas.openxmlformats.org/drawingml/2006/main">
               <a:ext uri="{FF2B5EF4-FFF2-40B4-BE49-F238E27FC236}">
-                <a16:creationId xmlns:a16="http://schemas.microsoft.com/office/drawing/2014/main" id="{A6C921EF-2379-4C8A-87C4-8384A20E28AD}"/>
+                <a16:creationId xmlns:a16="http://schemas.microsoft.com/office/drawing/2014/main" id="{2471DA5E-A30D-43E5-B896-D769BA4D520D}"/>
               </a:ext>
             </a:extLst>
           </p:cNvPr>
@@ -6532,7 +6532,7 @@
           <p:cNvPr id="3" name="">
             <a:extLst xmlns:a="http://schemas.openxmlformats.org/drawingml/2006/main">
               <a:ext uri="{FF2B5EF4-FFF2-40B4-BE49-F238E27FC236}">
-                <a16:creationId xmlns:a16="http://schemas.microsoft.com/office/drawing/2014/main" id="{5FCC7D8C-68AE-4262-80C4-F9185A111695}"/>
+                <a16:creationId xmlns:a16="http://schemas.microsoft.com/office/drawing/2014/main" id="{AB427355-3BAF-42E6-A5A8-22D595AAB517}"/>
               </a:ext>
             </a:extLst>
           </p:cNvPr>
@@ -6643,7 +6643,7 @@
                   <a:srgbClr val="FFFFFF"/>
                 </a:solidFill>
               </a:rPr>
-              <a:t>Материалы исследования, требования, схемы, прототип и план испытаний. Изменения слиты в main; CI прошёл.</a:t>
+              <a:t>Материалы исследования, требования, три обязательные схемы, прототип и план оценки подготовлены и опубликованы в GitHub.</a:t>
             </a:r>
           </a:p>
         </p:txBody>
@@ -6653,7 +6653,7 @@
           <p:cNvPr id="4" name="">
             <a:extLst xmlns:a="http://schemas.openxmlformats.org/drawingml/2006/main">
               <a:ext uri="{FF2B5EF4-FFF2-40B4-BE49-F238E27FC236}">
-                <a16:creationId xmlns:a16="http://schemas.microsoft.com/office/drawing/2014/main" id="{12644DB3-C37E-4C2D-B857-9A49A62F4E83}"/>
+                <a16:creationId xmlns:a16="http://schemas.microsoft.com/office/drawing/2014/main" id="{EF01DC3C-02F8-4C92-85AE-AFA333CB557F}"/>
               </a:ext>
             </a:extLst>
           </p:cNvPr>
@@ -6774,7 +6774,7 @@
           <p:cNvPr id="5" name="">
             <a:extLst xmlns:a="http://schemas.openxmlformats.org/drawingml/2006/main">
               <a:ext uri="{FF2B5EF4-FFF2-40B4-BE49-F238E27FC236}">
-                <a16:creationId xmlns:a16="http://schemas.microsoft.com/office/drawing/2014/main" id="{B37B8958-79C7-49D8-A801-C66CB5C18B2D}"/>
+                <a16:creationId xmlns:a16="http://schemas.microsoft.com/office/drawing/2014/main" id="{2DBD78F2-CEE9-47C5-9E9B-580A7F9FE998}"/>
               </a:ext>
             </a:extLst>
           </p:cNvPr>
@@ -6885,7 +6885,7 @@
                   <a:srgbClr val="FFFFFF"/>
                 </a:solidFill>
               </a:rPr>
-              <a:t>Реальное ревью второго участника до следующего слияния, отзыв руководителя, решение о многоэтапном маршруте и тег проверенной версии.</a:t>
+              <a:t>Личное ревью Әли до слияния следующего PR, решение о маршруте пилота, отзыв руководителя и тег проверенной версии.</a:t>
             </a:r>
           </a:p>
         </p:txBody>
@@ -6895,7 +6895,7 @@
           <p:cNvPr id="6" name="">
             <a:extLst xmlns:a="http://schemas.openxmlformats.org/drawingml/2006/main">
               <a:ext uri="{FF2B5EF4-FFF2-40B4-BE49-F238E27FC236}">
-                <a16:creationId xmlns:a16="http://schemas.microsoft.com/office/drawing/2014/main" id="{17267B60-E690-460A-ABE9-460FE27279EA}"/>
+                <a16:creationId xmlns:a16="http://schemas.microsoft.com/office/drawing/2014/main" id="{07EFF4BD-3558-4B30-9547-F5A66AF76743}"/>
               </a:ext>
             </a:extLst>
           </p:cNvPr>
@@ -7014,7 +7014,7 @@
     </p:spTree>
     <p:extLst>
       <p:ext uri="{BB962C8B-B14F-4D97-AF65-F5344CB8AC3E}">
-        <p14:creationId xmlns:p14="http://schemas.microsoft.com/office/powerpoint/2010/main" val="426170587"/>
+        <p14:creationId xmlns:p14="http://schemas.microsoft.com/office/powerpoint/2010/main" val="957871084"/>
       </p:ext>
     </p:extLst>
   </p:cSld>
@@ -7045,7 +7045,7 @@
           <p:cNvPr id="10" name="">
             <a:extLst xmlns:a="http://schemas.openxmlformats.org/drawingml/2006/main">
               <a:ext uri="{FF2B5EF4-FFF2-40B4-BE49-F238E27FC236}">
-                <a16:creationId xmlns:a16="http://schemas.microsoft.com/office/drawing/2014/main" id="{E43C5A60-0AA6-4408-93B9-3840B8017741}"/>
+                <a16:creationId xmlns:a16="http://schemas.microsoft.com/office/drawing/2014/main" id="{32D80D01-E6A2-4E6B-B283-7C79B0F90849}"/>
               </a:ext>
             </a:extLst>
           </p:cNvPr>
@@ -7166,7 +7166,7 @@
           <p:cNvPr id="2" name="">
             <a:extLst xmlns:a="http://schemas.openxmlformats.org/drawingml/2006/main">
               <a:ext uri="{FF2B5EF4-FFF2-40B4-BE49-F238E27FC236}">
-                <a16:creationId xmlns:a16="http://schemas.microsoft.com/office/drawing/2014/main" id="{5E454608-0A42-4DFE-8479-1A6AC340D006}"/>
+                <a16:creationId xmlns:a16="http://schemas.microsoft.com/office/drawing/2014/main" id="{F3006779-44B3-4E5A-9F5F-0C87EDDA34EB}"/>
               </a:ext>
             </a:extLst>
           </p:cNvPr>
@@ -7287,7 +7287,7 @@
           <p:cNvPr id="3" name="">
             <a:extLst xmlns:a="http://schemas.openxmlformats.org/drawingml/2006/main">
               <a:ext uri="{FF2B5EF4-FFF2-40B4-BE49-F238E27FC236}">
-                <a16:creationId xmlns:a16="http://schemas.microsoft.com/office/drawing/2014/main" id="{8D4D10DB-B38F-4972-91F2-C89E63CFA28F}"/>
+                <a16:creationId xmlns:a16="http://schemas.microsoft.com/office/drawing/2014/main" id="{24423EED-E11D-4B53-80EA-6D4879BD0129}"/>
               </a:ext>
             </a:extLst>
           </p:cNvPr>
@@ -7408,7 +7408,7 @@
           <p:cNvPr id="4" name="">
             <a:extLst xmlns:a="http://schemas.openxmlformats.org/drawingml/2006/main">
               <a:ext uri="{FF2B5EF4-FFF2-40B4-BE49-F238E27FC236}">
-                <a16:creationId xmlns:a16="http://schemas.microsoft.com/office/drawing/2014/main" id="{30ED6F4F-9E43-4BA7-B14D-DBDFEE204B10}"/>
+                <a16:creationId xmlns:a16="http://schemas.microsoft.com/office/drawing/2014/main" id="{91418950-4A85-407D-86E0-88158A2DD2E2}"/>
               </a:ext>
             </a:extLst>
           </p:cNvPr>
@@ -7529,7 +7529,7 @@
           <p:cNvPr id="5" name="">
             <a:extLst xmlns:a="http://schemas.openxmlformats.org/drawingml/2006/main">
               <a:ext uri="{FF2B5EF4-FFF2-40B4-BE49-F238E27FC236}">
-                <a16:creationId xmlns:a16="http://schemas.microsoft.com/office/drawing/2014/main" id="{938A6929-DBF3-4335-AC75-79D4966D0442}"/>
+                <a16:creationId xmlns:a16="http://schemas.microsoft.com/office/drawing/2014/main" id="{8BDD5E36-685E-4F70-A22D-B87BCBB6F54E}"/>
               </a:ext>
             </a:extLst>
           </p:cNvPr>
@@ -7650,7 +7650,7 @@
           <p:cNvPr id="6" name="">
             <a:extLst xmlns:a="http://schemas.openxmlformats.org/drawingml/2006/main">
               <a:ext uri="{FF2B5EF4-FFF2-40B4-BE49-F238E27FC236}">
-                <a16:creationId xmlns:a16="http://schemas.microsoft.com/office/drawing/2014/main" id="{F05665BB-6952-4A5E-A924-ED1AEA5DB942}"/>
+                <a16:creationId xmlns:a16="http://schemas.microsoft.com/office/drawing/2014/main" id="{C54C099B-EFC4-45FE-B6C9-F88AF900C384}"/>
               </a:ext>
             </a:extLst>
           </p:cNvPr>
@@ -7771,7 +7771,7 @@
           <p:cNvPr id="7" name="">
             <a:extLst xmlns:a="http://schemas.openxmlformats.org/drawingml/2006/main">
               <a:ext uri="{FF2B5EF4-FFF2-40B4-BE49-F238E27FC236}">
-                <a16:creationId xmlns:a16="http://schemas.microsoft.com/office/drawing/2014/main" id="{15276ED0-9C74-4719-AA7B-6D808A3CCB81}"/>
+                <a16:creationId xmlns:a16="http://schemas.microsoft.com/office/drawing/2014/main" id="{BC0704C7-1530-4CC1-A39F-29F33F680A9E}"/>
               </a:ext>
             </a:extLst>
           </p:cNvPr>
@@ -7892,7 +7892,7 @@
           <p:cNvPr id="8" name="">
             <a:extLst xmlns:a="http://schemas.openxmlformats.org/drawingml/2006/main">
               <a:ext uri="{FF2B5EF4-FFF2-40B4-BE49-F238E27FC236}">
-                <a16:creationId xmlns:a16="http://schemas.microsoft.com/office/drawing/2014/main" id="{2625CCF6-50E6-48AE-BDE1-4A5E86D058CA}"/>
+                <a16:creationId xmlns:a16="http://schemas.microsoft.com/office/drawing/2014/main" id="{554F670B-E728-4F81-A9B7-69845760ADBF}"/>
               </a:ext>
             </a:extLst>
           </p:cNvPr>
@@ -8013,7 +8013,7 @@
           <p:cNvPr id="9" name="">
             <a:extLst xmlns:a="http://schemas.openxmlformats.org/drawingml/2006/main">
               <a:ext uri="{FF2B5EF4-FFF2-40B4-BE49-F238E27FC236}">
-                <a16:creationId xmlns:a16="http://schemas.microsoft.com/office/drawing/2014/main" id="{566A18E8-B48C-4F86-90A1-C2D51035BB8C}"/>
+                <a16:creationId xmlns:a16="http://schemas.microsoft.com/office/drawing/2014/main" id="{09B59041-53FE-4182-9E09-E89874918BDD}"/>
               </a:ext>
             </a:extLst>
           </p:cNvPr>
@@ -8132,7 +8132,7 @@
     </p:spTree>
     <p:extLst>
       <p:ext uri="{BB962C8B-B14F-4D97-AF65-F5344CB8AC3E}">
-        <p14:creationId xmlns:p14="http://schemas.microsoft.com/office/powerpoint/2010/main" val="2043530494"/>
+        <p14:creationId xmlns:p14="http://schemas.microsoft.com/office/powerpoint/2010/main" val="1025245301"/>
       </p:ext>
     </p:extLst>
   </p:cSld>
@@ -8163,7 +8163,7 @@
           <p:cNvPr id="8" name="">
             <a:extLst xmlns:a="http://schemas.openxmlformats.org/drawingml/2006/main">
               <a:ext uri="{FF2B5EF4-FFF2-40B4-BE49-F238E27FC236}">
-                <a16:creationId xmlns:a16="http://schemas.microsoft.com/office/drawing/2014/main" id="{D353AE2E-5537-4D93-9E02-0050878F9AED}"/>
+                <a16:creationId xmlns:a16="http://schemas.microsoft.com/office/drawing/2014/main" id="{BC8B966F-7939-4220-9D85-DC69A5BD7E52}"/>
               </a:ext>
             </a:extLst>
           </p:cNvPr>
@@ -8284,7 +8284,7 @@
           <p:cNvPr id="2" name="">
             <a:extLst xmlns:a="http://schemas.openxmlformats.org/drawingml/2006/main">
               <a:ext uri="{FF2B5EF4-FFF2-40B4-BE49-F238E27FC236}">
-                <a16:creationId xmlns:a16="http://schemas.microsoft.com/office/drawing/2014/main" id="{7A1DAADA-D66E-4D4F-BA48-583CB9DFB903}"/>
+                <a16:creationId xmlns:a16="http://schemas.microsoft.com/office/drawing/2014/main" id="{91F3E9DF-F3E0-4737-95E9-5957DDAE5D11}"/>
               </a:ext>
             </a:extLst>
           </p:cNvPr>
@@ -8405,7 +8405,7 @@
           <p:cNvPr id="3" name="">
             <a:extLst xmlns:a="http://schemas.openxmlformats.org/drawingml/2006/main">
               <a:ext uri="{FF2B5EF4-FFF2-40B4-BE49-F238E27FC236}">
-                <a16:creationId xmlns:a16="http://schemas.microsoft.com/office/drawing/2014/main" id="{16424108-35D8-4F41-AC16-AC90CE070E4F}"/>
+                <a16:creationId xmlns:a16="http://schemas.microsoft.com/office/drawing/2014/main" id="{0773712C-AA05-4CC9-BD3E-34C56615BC5F}"/>
               </a:ext>
             </a:extLst>
           </p:cNvPr>
@@ -8526,7 +8526,7 @@
           <p:cNvPr id="4" name="">
             <a:extLst xmlns:a="http://schemas.openxmlformats.org/drawingml/2006/main">
               <a:ext uri="{FF2B5EF4-FFF2-40B4-BE49-F238E27FC236}">
-                <a16:creationId xmlns:a16="http://schemas.microsoft.com/office/drawing/2014/main" id="{82F263BF-ADFC-4AC4-880A-8FE1D3E1A726}"/>
+                <a16:creationId xmlns:a16="http://schemas.microsoft.com/office/drawing/2014/main" id="{7987A35E-4AD6-485C-BD4C-9A6A892D18EE}"/>
               </a:ext>
             </a:extLst>
           </p:cNvPr>
@@ -8647,7 +8647,7 @@
           <p:cNvPr id="5" name="">
             <a:extLst xmlns:a="http://schemas.openxmlformats.org/drawingml/2006/main">
               <a:ext uri="{FF2B5EF4-FFF2-40B4-BE49-F238E27FC236}">
-                <a16:creationId xmlns:a16="http://schemas.microsoft.com/office/drawing/2014/main" id="{BDD4D24C-6458-433B-B1EB-9ED5D3D5A768}"/>
+                <a16:creationId xmlns:a16="http://schemas.microsoft.com/office/drawing/2014/main" id="{10202083-2DAC-4B9D-9D8D-41E7095C2199}"/>
               </a:ext>
             </a:extLst>
           </p:cNvPr>
@@ -8768,7 +8768,7 @@
           <p:cNvPr id="6" name="">
             <a:extLst xmlns:a="http://schemas.openxmlformats.org/drawingml/2006/main">
               <a:ext uri="{FF2B5EF4-FFF2-40B4-BE49-F238E27FC236}">
-                <a16:creationId xmlns:a16="http://schemas.microsoft.com/office/drawing/2014/main" id="{BD1FDF2E-8FF9-4C57-9B66-8AFB9F355B67}"/>
+                <a16:creationId xmlns:a16="http://schemas.microsoft.com/office/drawing/2014/main" id="{6057C8AC-8693-4D43-A8DD-D9CA0411668F}"/>
               </a:ext>
             </a:extLst>
           </p:cNvPr>
@@ -8889,7 +8889,7 @@
           <p:cNvPr id="7" name="">
             <a:extLst xmlns:a="http://schemas.openxmlformats.org/drawingml/2006/main">
               <a:ext uri="{FF2B5EF4-FFF2-40B4-BE49-F238E27FC236}">
-                <a16:creationId xmlns:a16="http://schemas.microsoft.com/office/drawing/2014/main" id="{D5AC6DDB-3759-457D-91B6-A4734D344306}"/>
+                <a16:creationId xmlns:a16="http://schemas.microsoft.com/office/drawing/2014/main" id="{3AF3B541-7794-4B51-B9B0-C584D0FEF5E1}"/>
               </a:ext>
             </a:extLst>
           </p:cNvPr>
@@ -9008,7 +9008,7 @@
     </p:spTree>
     <p:extLst>
       <p:ext uri="{BB962C8B-B14F-4D97-AF65-F5344CB8AC3E}">
-        <p14:creationId xmlns:p14="http://schemas.microsoft.com/office/powerpoint/2010/main" val="1786797235"/>
+        <p14:creationId xmlns:p14="http://schemas.microsoft.com/office/powerpoint/2010/main" val="543696509"/>
       </p:ext>
     </p:extLst>
   </p:cSld>
@@ -9039,7 +9039,7 @@
           <p:cNvPr id="11" name="">
             <a:extLst xmlns:a="http://schemas.openxmlformats.org/drawingml/2006/main">
               <a:ext uri="{FF2B5EF4-FFF2-40B4-BE49-F238E27FC236}">
-                <a16:creationId xmlns:a16="http://schemas.microsoft.com/office/drawing/2014/main" id="{53DD463B-799E-496A-9960-14E241BADDB7}"/>
+                <a16:creationId xmlns:a16="http://schemas.microsoft.com/office/drawing/2014/main" id="{5CEDA31A-DC18-40FA-B9A8-A735742BA3F5}"/>
               </a:ext>
             </a:extLst>
           </p:cNvPr>
@@ -9160,7 +9160,7 @@
           <p:cNvPr id="2" name="">
             <a:extLst xmlns:a="http://schemas.openxmlformats.org/drawingml/2006/main">
               <a:ext uri="{FF2B5EF4-FFF2-40B4-BE49-F238E27FC236}">
-                <a16:creationId xmlns:a16="http://schemas.microsoft.com/office/drawing/2014/main" id="{6C814381-4022-4C5A-A3CE-245FCEA69306}"/>
+                <a16:creationId xmlns:a16="http://schemas.microsoft.com/office/drawing/2014/main" id="{103E26B9-8806-4CF6-88D9-620A94AF96C0}"/>
               </a:ext>
             </a:extLst>
           </p:cNvPr>
@@ -9281,7 +9281,7 @@
           <p:cNvPr id="3" name="">
             <a:extLst xmlns:a="http://schemas.openxmlformats.org/drawingml/2006/main">
               <a:ext uri="{FF2B5EF4-FFF2-40B4-BE49-F238E27FC236}">
-                <a16:creationId xmlns:a16="http://schemas.microsoft.com/office/drawing/2014/main" id="{6F32B2CD-5736-4B53-A00E-C5B4EB0308DA}"/>
+                <a16:creationId xmlns:a16="http://schemas.microsoft.com/office/drawing/2014/main" id="{3A674859-4912-4FC0-932D-86DCEE754714}"/>
               </a:ext>
             </a:extLst>
           </p:cNvPr>
@@ -9402,7 +9402,7 @@
           <p:cNvPr id="4" name="">
             <a:extLst xmlns:a="http://schemas.openxmlformats.org/drawingml/2006/main">
               <a:ext uri="{FF2B5EF4-FFF2-40B4-BE49-F238E27FC236}">
-                <a16:creationId xmlns:a16="http://schemas.microsoft.com/office/drawing/2014/main" id="{5D9FBF6E-616D-4715-AAEA-5F94509E9C3F}"/>
+                <a16:creationId xmlns:a16="http://schemas.microsoft.com/office/drawing/2014/main" id="{BC502336-8644-47BB-B315-B3476157527B}"/>
               </a:ext>
             </a:extLst>
           </p:cNvPr>
@@ -9523,7 +9523,7 @@
           <p:cNvPr id="5" name="">
             <a:extLst xmlns:a="http://schemas.openxmlformats.org/drawingml/2006/main">
               <a:ext uri="{FF2B5EF4-FFF2-40B4-BE49-F238E27FC236}">
-                <a16:creationId xmlns:a16="http://schemas.microsoft.com/office/drawing/2014/main" id="{C39E3BFD-34CD-4E52-AD60-155793F29D8B}"/>
+                <a16:creationId xmlns:a16="http://schemas.microsoft.com/office/drawing/2014/main" id="{BA6759B7-F157-4C92-A9AD-010E8A6D7D0F}"/>
               </a:ext>
             </a:extLst>
           </p:cNvPr>
@@ -9644,7 +9644,7 @@
           <p:cNvPr id="6" name="">
             <a:extLst xmlns:a="http://schemas.openxmlformats.org/drawingml/2006/main">
               <a:ext uri="{FF2B5EF4-FFF2-40B4-BE49-F238E27FC236}">
-                <a16:creationId xmlns:a16="http://schemas.microsoft.com/office/drawing/2014/main" id="{203DAB43-2272-409D-BA49-EB4DC2E4D2ED}"/>
+                <a16:creationId xmlns:a16="http://schemas.microsoft.com/office/drawing/2014/main" id="{71278208-A903-4456-B315-54E6122F7B20}"/>
               </a:ext>
             </a:extLst>
           </p:cNvPr>
@@ -9765,7 +9765,7 @@
           <p:cNvPr id="7" name="">
             <a:extLst xmlns:a="http://schemas.openxmlformats.org/drawingml/2006/main">
               <a:ext uri="{FF2B5EF4-FFF2-40B4-BE49-F238E27FC236}">
-                <a16:creationId xmlns:a16="http://schemas.microsoft.com/office/drawing/2014/main" id="{2B6C1FD1-CC85-4F31-B052-79EFB213F6E4}"/>
+                <a16:creationId xmlns:a16="http://schemas.microsoft.com/office/drawing/2014/main" id="{0301BAC6-BDF6-4DF5-BC67-7D78086009C3}"/>
               </a:ext>
             </a:extLst>
           </p:cNvPr>
@@ -9886,7 +9886,7 @@
           <p:cNvPr id="8" name="">
             <a:extLst xmlns:a="http://schemas.openxmlformats.org/drawingml/2006/main">
               <a:ext uri="{FF2B5EF4-FFF2-40B4-BE49-F238E27FC236}">
-                <a16:creationId xmlns:a16="http://schemas.microsoft.com/office/drawing/2014/main" id="{3BD5A458-BA68-4749-BB11-BBA8C0EB3461}"/>
+                <a16:creationId xmlns:a16="http://schemas.microsoft.com/office/drawing/2014/main" id="{D448C6FA-F0AE-4028-8E01-410303CA63B0}"/>
               </a:ext>
             </a:extLst>
           </p:cNvPr>
@@ -10007,7 +10007,7 @@
           <p:cNvPr id="9" name="">
             <a:extLst xmlns:a="http://schemas.openxmlformats.org/drawingml/2006/main">
               <a:ext uri="{FF2B5EF4-FFF2-40B4-BE49-F238E27FC236}">
-                <a16:creationId xmlns:a16="http://schemas.microsoft.com/office/drawing/2014/main" id="{CB2C7838-6841-4C03-BC77-1F02AE6E313D}"/>
+                <a16:creationId xmlns:a16="http://schemas.microsoft.com/office/drawing/2014/main" id="{B6DE2EB1-FEF8-48A3-9584-1E9B4C16B343}"/>
               </a:ext>
             </a:extLst>
           </p:cNvPr>
@@ -10128,7 +10128,7 @@
           <p:cNvPr id="10" name="">
             <a:extLst xmlns:a="http://schemas.openxmlformats.org/drawingml/2006/main">
               <a:ext uri="{FF2B5EF4-FFF2-40B4-BE49-F238E27FC236}">
-                <a16:creationId xmlns:a16="http://schemas.microsoft.com/office/drawing/2014/main" id="{5CE7FDC4-903A-4570-AC8B-89D451EBD226}"/>
+                <a16:creationId xmlns:a16="http://schemas.microsoft.com/office/drawing/2014/main" id="{7E331728-07EE-4193-A9A6-944B343AFA3E}"/>
               </a:ext>
             </a:extLst>
           </p:cNvPr>
@@ -10247,7 +10247,7 @@
     </p:spTree>
     <p:extLst>
       <p:ext uri="{BB962C8B-B14F-4D97-AF65-F5344CB8AC3E}">
-        <p14:creationId xmlns:p14="http://schemas.microsoft.com/office/powerpoint/2010/main" val="1033779037"/>
+        <p14:creationId xmlns:p14="http://schemas.microsoft.com/office/powerpoint/2010/main" val="1654721534"/>
       </p:ext>
     </p:extLst>
   </p:cSld>
@@ -10278,7 +10278,7 @@
           <p:cNvPr id="7" name="">
             <a:extLst xmlns:a="http://schemas.openxmlformats.org/drawingml/2006/main">
               <a:ext uri="{FF2B5EF4-FFF2-40B4-BE49-F238E27FC236}">
-                <a16:creationId xmlns:a16="http://schemas.microsoft.com/office/drawing/2014/main" id="{002AD1E5-006D-41F1-8D76-1F7F85ABE1B0}"/>
+                <a16:creationId xmlns:a16="http://schemas.microsoft.com/office/drawing/2014/main" id="{90A409F5-A43E-4566-AED4-0792FE9006BF}"/>
               </a:ext>
             </a:extLst>
           </p:cNvPr>
@@ -10399,7 +10399,7 @@
           <p:cNvPr id="2" name="">
             <a:extLst xmlns:a="http://schemas.openxmlformats.org/drawingml/2006/main">
               <a:ext uri="{FF2B5EF4-FFF2-40B4-BE49-F238E27FC236}">
-                <a16:creationId xmlns:a16="http://schemas.microsoft.com/office/drawing/2014/main" id="{CB63E7F7-41D4-4A53-8AE3-536BAB143CBE}"/>
+                <a16:creationId xmlns:a16="http://schemas.microsoft.com/office/drawing/2014/main" id="{FC14DA6C-F0A2-4B36-9C83-CF8AA7CBB847}"/>
               </a:ext>
             </a:extLst>
           </p:cNvPr>
@@ -10520,7 +10520,7 @@
           <p:cNvPr id="3" name="">
             <a:extLst xmlns:a="http://schemas.openxmlformats.org/drawingml/2006/main">
               <a:ext uri="{FF2B5EF4-FFF2-40B4-BE49-F238E27FC236}">
-                <a16:creationId xmlns:a16="http://schemas.microsoft.com/office/drawing/2014/main" id="{18F0C0CB-D453-4623-9AAD-0FFBE9760A69}"/>
+                <a16:creationId xmlns:a16="http://schemas.microsoft.com/office/drawing/2014/main" id="{61803C13-483D-452E-9D1F-A5515B65B32F}"/>
               </a:ext>
             </a:extLst>
           </p:cNvPr>
@@ -10709,7 +10709,7 @@
           <p:cNvPr id="4" name="">
             <a:extLst xmlns:a="http://schemas.openxmlformats.org/drawingml/2006/main">
               <a:ext uri="{FF2B5EF4-FFF2-40B4-BE49-F238E27FC236}">
-                <a16:creationId xmlns:a16="http://schemas.microsoft.com/office/drawing/2014/main" id="{E3415BB0-C617-4E5C-A5FE-E4E4B17E356C}"/>
+                <a16:creationId xmlns:a16="http://schemas.microsoft.com/office/drawing/2014/main" id="{C5354622-2C69-4B08-A16A-776B12BEFEC8}"/>
               </a:ext>
             </a:extLst>
           </p:cNvPr>
@@ -10830,7 +10830,7 @@
           <p:cNvPr id="5" name="">
             <a:extLst xmlns:a="http://schemas.openxmlformats.org/drawingml/2006/main">
               <a:ext uri="{FF2B5EF4-FFF2-40B4-BE49-F238E27FC236}">
-                <a16:creationId xmlns:a16="http://schemas.microsoft.com/office/drawing/2014/main" id="{0C415271-7384-487D-AD5B-366C67903620}"/>
+                <a16:creationId xmlns:a16="http://schemas.microsoft.com/office/drawing/2014/main" id="{94CC162D-DE99-4E05-AE46-B2E6DEFD9885}"/>
               </a:ext>
             </a:extLst>
           </p:cNvPr>
@@ -10968,7 +10968,7 @@
           <p:cNvPr id="6" name="">
             <a:extLst xmlns:a="http://schemas.openxmlformats.org/drawingml/2006/main">
               <a:ext uri="{FF2B5EF4-FFF2-40B4-BE49-F238E27FC236}">
-                <a16:creationId xmlns:a16="http://schemas.microsoft.com/office/drawing/2014/main" id="{A32D4A3D-C9F7-47A3-8445-DD62B7AE7762}"/>
+                <a16:creationId xmlns:a16="http://schemas.microsoft.com/office/drawing/2014/main" id="{5A024F42-21B7-4C4D-BAC8-174FA8B5EEB4}"/>
               </a:ext>
             </a:extLst>
           </p:cNvPr>
@@ -11087,7 +11087,7 @@
     </p:spTree>
     <p:extLst>
       <p:ext uri="{BB962C8B-B14F-4D97-AF65-F5344CB8AC3E}">
-        <p14:creationId xmlns:p14="http://schemas.microsoft.com/office/powerpoint/2010/main" val="237743538"/>
+        <p14:creationId xmlns:p14="http://schemas.microsoft.com/office/powerpoint/2010/main" val="311204768"/>
       </p:ext>
     </p:extLst>
   </p:cSld>
@@ -11118,7 +11118,7 @@
           <p:cNvPr id="10" name="">
             <a:extLst xmlns:a="http://schemas.openxmlformats.org/drawingml/2006/main">
               <a:ext uri="{FF2B5EF4-FFF2-40B4-BE49-F238E27FC236}">
-                <a16:creationId xmlns:a16="http://schemas.microsoft.com/office/drawing/2014/main" id="{AA2A827F-4B27-4BF9-9F80-03B7C1CEAEFF}"/>
+                <a16:creationId xmlns:a16="http://schemas.microsoft.com/office/drawing/2014/main" id="{86928A2E-0F90-4574-BEB0-A1B35A877D2F}"/>
               </a:ext>
             </a:extLst>
           </p:cNvPr>
@@ -11239,7 +11239,7 @@
           <p:cNvPr id="2" name="">
             <a:extLst xmlns:a="http://schemas.openxmlformats.org/drawingml/2006/main">
               <a:ext uri="{FF2B5EF4-FFF2-40B4-BE49-F238E27FC236}">
-                <a16:creationId xmlns:a16="http://schemas.microsoft.com/office/drawing/2014/main" id="{A8CA494B-259F-49AD-99A1-256A377C1C85}"/>
+                <a16:creationId xmlns:a16="http://schemas.microsoft.com/office/drawing/2014/main" id="{3ED011E7-B569-421C-89E7-846A0490E4E5}"/>
               </a:ext>
             </a:extLst>
           </p:cNvPr>
@@ -11360,7 +11360,7 @@
           <p:cNvPr id="3" name="">
             <a:extLst xmlns:a="http://schemas.openxmlformats.org/drawingml/2006/main">
               <a:ext uri="{FF2B5EF4-FFF2-40B4-BE49-F238E27FC236}">
-                <a16:creationId xmlns:a16="http://schemas.microsoft.com/office/drawing/2014/main" id="{61986073-1961-4419-B727-D17CA110D9DF}"/>
+                <a16:creationId xmlns:a16="http://schemas.microsoft.com/office/drawing/2014/main" id="{073C3C2E-5736-4A5F-B17E-354C7514847E}"/>
               </a:ext>
             </a:extLst>
           </p:cNvPr>
@@ -11481,7 +11481,7 @@
           <p:cNvPr id="4" name="">
             <a:extLst xmlns:a="http://schemas.openxmlformats.org/drawingml/2006/main">
               <a:ext uri="{FF2B5EF4-FFF2-40B4-BE49-F238E27FC236}">
-                <a16:creationId xmlns:a16="http://schemas.microsoft.com/office/drawing/2014/main" id="{646F7BB6-453A-410A-93B2-087FBE649B0F}"/>
+                <a16:creationId xmlns:a16="http://schemas.microsoft.com/office/drawing/2014/main" id="{41AC9CC6-644E-4386-AD50-D6851418137F}"/>
               </a:ext>
             </a:extLst>
           </p:cNvPr>
@@ -11602,7 +11602,7 @@
           <p:cNvPr id="5" name="">
             <a:extLst xmlns:a="http://schemas.openxmlformats.org/drawingml/2006/main">
               <a:ext uri="{FF2B5EF4-FFF2-40B4-BE49-F238E27FC236}">
-                <a16:creationId xmlns:a16="http://schemas.microsoft.com/office/drawing/2014/main" id="{0EC42F34-840E-43D7-B000-7E03986CFF63}"/>
+                <a16:creationId xmlns:a16="http://schemas.microsoft.com/office/drawing/2014/main" id="{4899E77D-2FC0-4085-9F82-DBE2013E157E}"/>
               </a:ext>
             </a:extLst>
           </p:cNvPr>
@@ -11723,7 +11723,7 @@
           <p:cNvPr id="6" name="">
             <a:extLst xmlns:a="http://schemas.openxmlformats.org/drawingml/2006/main">
               <a:ext uri="{FF2B5EF4-FFF2-40B4-BE49-F238E27FC236}">
-                <a16:creationId xmlns:a16="http://schemas.microsoft.com/office/drawing/2014/main" id="{77D24573-9826-48D0-B5EB-CA4A79D600FD}"/>
+                <a16:creationId xmlns:a16="http://schemas.microsoft.com/office/drawing/2014/main" id="{036A1FD5-FE23-4691-80B1-0DC3E4094DB9}"/>
               </a:ext>
             </a:extLst>
           </p:cNvPr>
@@ -11844,7 +11844,7 @@
           <p:cNvPr id="7" name="">
             <a:extLst xmlns:a="http://schemas.openxmlformats.org/drawingml/2006/main">
               <a:ext uri="{FF2B5EF4-FFF2-40B4-BE49-F238E27FC236}">
-                <a16:creationId xmlns:a16="http://schemas.microsoft.com/office/drawing/2014/main" id="{59376230-695E-4EC2-BE0E-1EDFB9AAC206}"/>
+                <a16:creationId xmlns:a16="http://schemas.microsoft.com/office/drawing/2014/main" id="{9BAF9851-7AD3-41A4-B3FF-2A6A8E4A108C}"/>
               </a:ext>
             </a:extLst>
           </p:cNvPr>
@@ -11965,7 +11965,7 @@
           <p:cNvPr id="8" name="">
             <a:extLst xmlns:a="http://schemas.openxmlformats.org/drawingml/2006/main">
               <a:ext uri="{FF2B5EF4-FFF2-40B4-BE49-F238E27FC236}">
-                <a16:creationId xmlns:a16="http://schemas.microsoft.com/office/drawing/2014/main" id="{164F3F6D-37F8-4750-BB73-38E9616EBD38}"/>
+                <a16:creationId xmlns:a16="http://schemas.microsoft.com/office/drawing/2014/main" id="{FF434590-EF93-4517-8369-9B3D99415842}"/>
               </a:ext>
             </a:extLst>
           </p:cNvPr>
@@ -12086,7 +12086,7 @@
           <p:cNvPr id="9" name="">
             <a:extLst xmlns:a="http://schemas.openxmlformats.org/drawingml/2006/main">
               <a:ext uri="{FF2B5EF4-FFF2-40B4-BE49-F238E27FC236}">
-                <a16:creationId xmlns:a16="http://schemas.microsoft.com/office/drawing/2014/main" id="{42E96E47-13CF-432D-857D-808EB266CFCE}"/>
+                <a16:creationId xmlns:a16="http://schemas.microsoft.com/office/drawing/2014/main" id="{DA8E0E7F-AB19-4C03-BAFE-B83CE64A9B0C}"/>
               </a:ext>
             </a:extLst>
           </p:cNvPr>
@@ -12205,7 +12205,7 @@
     </p:spTree>
     <p:extLst>
       <p:ext uri="{BB962C8B-B14F-4D97-AF65-F5344CB8AC3E}">
-        <p14:creationId xmlns:p14="http://schemas.microsoft.com/office/powerpoint/2010/main" val="466942032"/>
+        <p14:creationId xmlns:p14="http://schemas.microsoft.com/office/powerpoint/2010/main" val="1271725175"/>
       </p:ext>
     </p:extLst>
   </p:cSld>
@@ -12236,7 +12236,7 @@
           <p:cNvPr id="12" name="">
             <a:extLst xmlns:a="http://schemas.openxmlformats.org/drawingml/2006/main">
               <a:ext uri="{FF2B5EF4-FFF2-40B4-BE49-F238E27FC236}">
-                <a16:creationId xmlns:a16="http://schemas.microsoft.com/office/drawing/2014/main" id="{D815142C-4F7A-4174-A3C8-5D6AC328D3CF}"/>
+                <a16:creationId xmlns:a16="http://schemas.microsoft.com/office/drawing/2014/main" id="{EAE062D6-8DB7-49F9-85CD-B8FCA0174997}"/>
               </a:ext>
             </a:extLst>
           </p:cNvPr>
@@ -12357,7 +12357,7 @@
           <p:cNvPr id="2" name="">
             <a:extLst xmlns:a="http://schemas.openxmlformats.org/drawingml/2006/main">
               <a:ext uri="{FF2B5EF4-FFF2-40B4-BE49-F238E27FC236}">
-                <a16:creationId xmlns:a16="http://schemas.microsoft.com/office/drawing/2014/main" id="{D0F3A4DB-1A62-4885-95AB-633F9AC8539E}"/>
+                <a16:creationId xmlns:a16="http://schemas.microsoft.com/office/drawing/2014/main" id="{284D47FC-CFE0-4AD1-ACF6-36152FCECC29}"/>
               </a:ext>
             </a:extLst>
           </p:cNvPr>
@@ -12478,7 +12478,7 @@
           <p:cNvPr id="3" name="">
             <a:extLst xmlns:a="http://schemas.openxmlformats.org/drawingml/2006/main">
               <a:ext uri="{FF2B5EF4-FFF2-40B4-BE49-F238E27FC236}">
-                <a16:creationId xmlns:a16="http://schemas.microsoft.com/office/drawing/2014/main" id="{095AFC9A-CEEF-4DA7-A9C0-ACB832D97A97}"/>
+                <a16:creationId xmlns:a16="http://schemas.microsoft.com/office/drawing/2014/main" id="{85A4EFA2-A8C1-430B-8DB7-68A22D693448}"/>
               </a:ext>
             </a:extLst>
           </p:cNvPr>
@@ -12599,7 +12599,7 @@
           <p:cNvPr id="4" name="">
             <a:extLst xmlns:a="http://schemas.openxmlformats.org/drawingml/2006/main">
               <a:ext uri="{FF2B5EF4-FFF2-40B4-BE49-F238E27FC236}">
-                <a16:creationId xmlns:a16="http://schemas.microsoft.com/office/drawing/2014/main" id="{2825B8A3-289E-4731-8161-CBA7F9A8D5C8}"/>
+                <a16:creationId xmlns:a16="http://schemas.microsoft.com/office/drawing/2014/main" id="{102057B4-A84C-4977-BFB4-D76BC99E6513}"/>
               </a:ext>
             </a:extLst>
           </p:cNvPr>
@@ -12720,7 +12720,7 @@
           <p:cNvPr id="5" name="">
             <a:extLst xmlns:a="http://schemas.openxmlformats.org/drawingml/2006/main">
               <a:ext uri="{FF2B5EF4-FFF2-40B4-BE49-F238E27FC236}">
-                <a16:creationId xmlns:a16="http://schemas.microsoft.com/office/drawing/2014/main" id="{2B0550A0-97C1-45F6-AE62-0B0D5AC0C19F}"/>
+                <a16:creationId xmlns:a16="http://schemas.microsoft.com/office/drawing/2014/main" id="{652C7EB8-6115-44C7-85A0-F0A3B27D8C39}"/>
               </a:ext>
             </a:extLst>
           </p:cNvPr>
@@ -12841,7 +12841,7 @@
           <p:cNvPr id="6" name="">
             <a:extLst xmlns:a="http://schemas.openxmlformats.org/drawingml/2006/main">
               <a:ext uri="{FF2B5EF4-FFF2-40B4-BE49-F238E27FC236}">
-                <a16:creationId xmlns:a16="http://schemas.microsoft.com/office/drawing/2014/main" id="{2A3190A6-E7D5-4DEE-A0AB-C25FAB2FACD3}"/>
+                <a16:creationId xmlns:a16="http://schemas.microsoft.com/office/drawing/2014/main" id="{48C33544-390A-4C5C-A053-ED86661FBAE9}"/>
               </a:ext>
             </a:extLst>
           </p:cNvPr>
@@ -12962,7 +12962,7 @@
           <p:cNvPr id="7" name="">
             <a:extLst xmlns:a="http://schemas.openxmlformats.org/drawingml/2006/main">
               <a:ext uri="{FF2B5EF4-FFF2-40B4-BE49-F238E27FC236}">
-                <a16:creationId xmlns:a16="http://schemas.microsoft.com/office/drawing/2014/main" id="{518CD7B2-562A-4774-8AB1-6C6A5F906AA4}"/>
+                <a16:creationId xmlns:a16="http://schemas.microsoft.com/office/drawing/2014/main" id="{F82E14A9-BC5C-4269-9E27-8EB7C9001E61}"/>
               </a:ext>
             </a:extLst>
           </p:cNvPr>
@@ -13083,7 +13083,7 @@
           <p:cNvPr id="8" name="">
             <a:extLst xmlns:a="http://schemas.openxmlformats.org/drawingml/2006/main">
               <a:ext uri="{FF2B5EF4-FFF2-40B4-BE49-F238E27FC236}">
-                <a16:creationId xmlns:a16="http://schemas.microsoft.com/office/drawing/2014/main" id="{165C15B6-A9B5-4F14-BF57-A30CEA41143A}"/>
+                <a16:creationId xmlns:a16="http://schemas.microsoft.com/office/drawing/2014/main" id="{E95D15CF-663A-431C-8818-CE9A0D9B06F4}"/>
               </a:ext>
             </a:extLst>
           </p:cNvPr>
@@ -13204,7 +13204,7 @@
           <p:cNvPr id="9" name="">
             <a:extLst xmlns:a="http://schemas.openxmlformats.org/drawingml/2006/main">
               <a:ext uri="{FF2B5EF4-FFF2-40B4-BE49-F238E27FC236}">
-                <a16:creationId xmlns:a16="http://schemas.microsoft.com/office/drawing/2014/main" id="{67146E44-0323-4283-99EA-3F6D4C829226}"/>
+                <a16:creationId xmlns:a16="http://schemas.microsoft.com/office/drawing/2014/main" id="{E3F189D8-2A73-4B2C-8518-360AC27BBA9B}"/>
               </a:ext>
             </a:extLst>
           </p:cNvPr>
@@ -13325,7 +13325,7 @@
           <p:cNvPr id="10" name="">
             <a:extLst xmlns:a="http://schemas.openxmlformats.org/drawingml/2006/main">
               <a:ext uri="{FF2B5EF4-FFF2-40B4-BE49-F238E27FC236}">
-                <a16:creationId xmlns:a16="http://schemas.microsoft.com/office/drawing/2014/main" id="{CB180C25-D4B3-4B4E-A5D9-BF28704E8B78}"/>
+                <a16:creationId xmlns:a16="http://schemas.microsoft.com/office/drawing/2014/main" id="{CE49FFE3-023C-4F41-B402-2193C2AB6B82}"/>
               </a:ext>
             </a:extLst>
           </p:cNvPr>
@@ -13446,7 +13446,7 @@
           <p:cNvPr id="11" name="">
             <a:extLst xmlns:a="http://schemas.openxmlformats.org/drawingml/2006/main">
               <a:ext uri="{FF2B5EF4-FFF2-40B4-BE49-F238E27FC236}">
-                <a16:creationId xmlns:a16="http://schemas.microsoft.com/office/drawing/2014/main" id="{D0F92D15-3169-4503-9226-D9747DF81C89}"/>
+                <a16:creationId xmlns:a16="http://schemas.microsoft.com/office/drawing/2014/main" id="{3F50E158-AAD4-4CCC-9980-A8B055E3747E}"/>
               </a:ext>
             </a:extLst>
           </p:cNvPr>
@@ -13565,7 +13565,7 @@
     </p:spTree>
     <p:extLst>
       <p:ext uri="{BB962C8B-B14F-4D97-AF65-F5344CB8AC3E}">
-        <p14:creationId xmlns:p14="http://schemas.microsoft.com/office/powerpoint/2010/main" val="1046638678"/>
+        <p14:creationId xmlns:p14="http://schemas.microsoft.com/office/powerpoint/2010/main" val="761753319"/>
       </p:ext>
     </p:extLst>
   </p:cSld>
@@ -13596,7 +13596,7 @@
           <p:cNvPr id="6" name="">
             <a:extLst xmlns:a="http://schemas.openxmlformats.org/drawingml/2006/main">
               <a:ext uri="{FF2B5EF4-FFF2-40B4-BE49-F238E27FC236}">
-                <a16:creationId xmlns:a16="http://schemas.microsoft.com/office/drawing/2014/main" id="{6F18C6D2-F7A7-470C-A217-4F6D847CFAB4}"/>
+                <a16:creationId xmlns:a16="http://schemas.microsoft.com/office/drawing/2014/main" id="{7CF2C31F-94F7-4FB8-B834-20FF0302774B}"/>
               </a:ext>
             </a:extLst>
           </p:cNvPr>
@@ -13717,7 +13717,7 @@
           <p:cNvPr id="2" name="">
             <a:extLst xmlns:a="http://schemas.openxmlformats.org/drawingml/2006/main">
               <a:ext uri="{FF2B5EF4-FFF2-40B4-BE49-F238E27FC236}">
-                <a16:creationId xmlns:a16="http://schemas.microsoft.com/office/drawing/2014/main" id="{85ABA607-9CC7-43B2-BF69-7B2AD7B78056}"/>
+                <a16:creationId xmlns:a16="http://schemas.microsoft.com/office/drawing/2014/main" id="{ED2715CB-D89C-44CE-9E74-C5D2F929B541}"/>
               </a:ext>
             </a:extLst>
           </p:cNvPr>
@@ -13838,7 +13838,7 @@
           <p:cNvPr id="3" name="">
             <a:extLst xmlns:a="http://schemas.openxmlformats.org/drawingml/2006/main">
               <a:ext uri="{FF2B5EF4-FFF2-40B4-BE49-F238E27FC236}">
-                <a16:creationId xmlns:a16="http://schemas.microsoft.com/office/drawing/2014/main" id="{6CEB9F52-59FD-4CE5-90CA-AD394E4B00A8}"/>
+                <a16:creationId xmlns:a16="http://schemas.microsoft.com/office/drawing/2014/main" id="{25C9ED6A-BEC5-4C4F-9A4A-192495A0A391}"/>
               </a:ext>
             </a:extLst>
           </p:cNvPr>
@@ -13848,7 +13848,7 @@
           <p:nvPr/>
         </p:nvPicPr>
         <p:blipFill>
-          <a:blip xmlns:r="http://schemas.openxmlformats.org/officeDocument/2006/relationships" xmlns:a="http://schemas.openxmlformats.org/drawingml/2006/main" r:embed="R11d3edcf893e4741"/>
+          <a:blip xmlns:r="http://schemas.openxmlformats.org/officeDocument/2006/relationships" xmlns:a="http://schemas.openxmlformats.org/drawingml/2006/main" r:embed="R450ef278945f42ab"/>
           <a:stretch xmlns:a="http://schemas.openxmlformats.org/drawingml/2006/main"/>
         </p:blipFill>
         <p:spPr>
@@ -13866,7 +13866,7 @@
           <p:cNvPr id="4" name="">
             <a:extLst xmlns:a="http://schemas.openxmlformats.org/drawingml/2006/main">
               <a:ext uri="{FF2B5EF4-FFF2-40B4-BE49-F238E27FC236}">
-                <a16:creationId xmlns:a16="http://schemas.microsoft.com/office/drawing/2014/main" id="{F7448F73-9CB0-4B96-AACE-3FB5486E627C}"/>
+                <a16:creationId xmlns:a16="http://schemas.microsoft.com/office/drawing/2014/main" id="{72D6DEB4-BA21-4007-A89E-3D3103A08723}"/>
               </a:ext>
             </a:extLst>
           </p:cNvPr>
@@ -13987,7 +13987,7 @@
           <p:cNvPr id="5" name="">
             <a:extLst xmlns:a="http://schemas.openxmlformats.org/drawingml/2006/main">
               <a:ext uri="{FF2B5EF4-FFF2-40B4-BE49-F238E27FC236}">
-                <a16:creationId xmlns:a16="http://schemas.microsoft.com/office/drawing/2014/main" id="{90D78269-615D-44B1-A689-E43CA7290A8A}"/>
+                <a16:creationId xmlns:a16="http://schemas.microsoft.com/office/drawing/2014/main" id="{2D0F8A9D-546E-4D44-A2FF-A527956F8DC8}"/>
               </a:ext>
             </a:extLst>
           </p:cNvPr>
@@ -14106,7 +14106,7 @@
     </p:spTree>
     <p:extLst>
       <p:ext uri="{BB962C8B-B14F-4D97-AF65-F5344CB8AC3E}">
-        <p14:creationId xmlns:p14="http://schemas.microsoft.com/office/powerpoint/2010/main" val="968774711"/>
+        <p14:creationId xmlns:p14="http://schemas.microsoft.com/office/powerpoint/2010/main" val="330591722"/>
       </p:ext>
     </p:extLst>
   </p:cSld>
@@ -14137,7 +14137,7 @@
           <p:cNvPr id="6" name="">
             <a:extLst xmlns:a="http://schemas.openxmlformats.org/drawingml/2006/main">
               <a:ext uri="{FF2B5EF4-FFF2-40B4-BE49-F238E27FC236}">
-                <a16:creationId xmlns:a16="http://schemas.microsoft.com/office/drawing/2014/main" id="{71891791-F5C5-43A9-A777-ADA86F894C2E}"/>
+                <a16:creationId xmlns:a16="http://schemas.microsoft.com/office/drawing/2014/main" id="{0C17208E-6AD5-42B0-83A5-BB32E878BDEC}"/>
               </a:ext>
             </a:extLst>
           </p:cNvPr>
@@ -14248,7 +14248,7 @@
                   <a:srgbClr val="152C3D"/>
                 </a:solidFill>
               </a:rPr>
-              <a:t>Жизненный цикл документа</a:t>
+              <a:t>UML-сценарии пользователей</a:t>
             </a:r>
           </a:p>
         </p:txBody>
@@ -14258,7 +14258,7 @@
           <p:cNvPr id="2" name="">
             <a:extLst xmlns:a="http://schemas.openxmlformats.org/drawingml/2006/main">
               <a:ext uri="{FF2B5EF4-FFF2-40B4-BE49-F238E27FC236}">
-                <a16:creationId xmlns:a16="http://schemas.microsoft.com/office/drawing/2014/main" id="{2FBE2CEA-5FC4-4147-ABE7-123966FBE5E6}"/>
+                <a16:creationId xmlns:a16="http://schemas.microsoft.com/office/drawing/2014/main" id="{D32C713A-240F-4D80-B942-98A4B96781DC}"/>
               </a:ext>
             </a:extLst>
           </p:cNvPr>
@@ -14379,7 +14379,7 @@
           <p:cNvPr id="3" name="">
             <a:extLst xmlns:a="http://schemas.openxmlformats.org/drawingml/2006/main">
               <a:ext uri="{FF2B5EF4-FFF2-40B4-BE49-F238E27FC236}">
-                <a16:creationId xmlns:a16="http://schemas.microsoft.com/office/drawing/2014/main" id="{0294739A-9E22-4A22-A80A-826190553864}"/>
+                <a16:creationId xmlns:a16="http://schemas.microsoft.com/office/drawing/2014/main" id="{A66BAD50-5A7E-44FD-A6CE-68EFB69E86DB}"/>
               </a:ext>
             </a:extLst>
           </p:cNvPr>
@@ -14389,7 +14389,7 @@
           <p:nvPr/>
         </p:nvPicPr>
         <p:blipFill>
-          <a:blip xmlns:r="http://schemas.openxmlformats.org/officeDocument/2006/relationships" xmlns:a="http://schemas.openxmlformats.org/drawingml/2006/main" r:embed="R643581e1fd1f49a6"/>
+          <a:blip xmlns:r="http://schemas.openxmlformats.org/officeDocument/2006/relationships" xmlns:a="http://schemas.openxmlformats.org/drawingml/2006/main" r:embed="Rd36a787541ef4879"/>
           <a:stretch xmlns:a="http://schemas.openxmlformats.org/drawingml/2006/main"/>
         </p:blipFill>
         <p:spPr>
@@ -14407,7 +14407,7 @@
           <p:cNvPr id="4" name="">
             <a:extLst xmlns:a="http://schemas.openxmlformats.org/drawingml/2006/main">
               <a:ext uri="{FF2B5EF4-FFF2-40B4-BE49-F238E27FC236}">
-                <a16:creationId xmlns:a16="http://schemas.microsoft.com/office/drawing/2014/main" id="{11702B28-4F5E-4B5B-AE02-54AC644A9570}"/>
+                <a16:creationId xmlns:a16="http://schemas.microsoft.com/office/drawing/2014/main" id="{9AEE9F8B-A8FA-46D4-821F-96DC80160DE0}"/>
               </a:ext>
             </a:extLst>
           </p:cNvPr>
@@ -14528,7 +14528,7 @@
           <p:cNvPr id="5" name="">
             <a:extLst xmlns:a="http://schemas.openxmlformats.org/drawingml/2006/main">
               <a:ext uri="{FF2B5EF4-FFF2-40B4-BE49-F238E27FC236}">
-                <a16:creationId xmlns:a16="http://schemas.microsoft.com/office/drawing/2014/main" id="{3B70D797-9BF2-47BF-BB77-D5FF01A32D25}"/>
+                <a16:creationId xmlns:a16="http://schemas.microsoft.com/office/drawing/2014/main" id="{0B13B551-A258-4180-AE0B-C9B8B820FE88}"/>
               </a:ext>
             </a:extLst>
           </p:cNvPr>
@@ -14639,7 +14639,7 @@
                   <a:srgbClr val="4F6474"/>
                 </a:solidFill>
               </a:rPr>
-              <a:t>Последовательные этапы из интервью описаны как кандидат для следующего шага.</a:t>
+              <a:t>Последовательные согласующие из интервью остаются вопросом для пилота.</a:t>
             </a:r>
           </a:p>
         </p:txBody>
@@ -14647,7 +14647,7 @@
     </p:spTree>
     <p:extLst>
       <p:ext uri="{BB962C8B-B14F-4D97-AF65-F5344CB8AC3E}">
-        <p14:creationId xmlns:p14="http://schemas.microsoft.com/office/powerpoint/2010/main" val="989745017"/>
+        <p14:creationId xmlns:p14="http://schemas.microsoft.com/office/powerpoint/2010/main" val="1725162415"/>
       </p:ext>
     </p:extLst>
   </p:cSld>

</xml_diff>